<commit_message>
docs(présentation): monitoring cron + Telegram (Prometheus/Grafana en cible), backup Google Drive opérationnel
Soutenance (pptx) et documentation Bloc 4 (docx) affirmaient une stack
Prometheus + Grafana + Alertmanager « redéployée le 2026-07-02, 5/5 cibles
up » et un backup offsite « en attente / non fonctionnel ». Sur le VPS
aujourd'hui : aucun container de monitoring, alertes par cron + Telegram ;
backup quotidien vers Google Drive opérationnel depuis le 2026-09-23.

- pptx : slides 5 (stack), 16 (C6 infrastructure), 17 (services, backup),
  diagramme de flux de la slide 7 réexporté.
- docx : §9.2 réécrit (watchdog, taux d'échec DAGs avec hystérésis, alerte
  backup, cible Prometheus/Grafana), §10.2, §10.3 (backup Drive + transparence
  sur les 2 mois sans backup), §10.4, §10.5, boucle MLOps, note de version,
  déclaration du type png manquante dans [Content_Types].xml.
- drawio 01 et 02 : monitoring marqué cible non déployée, backup Google Drive.
</commit_message>
<xml_diff>
--- a/présentation/LyonFlow_Bloc4_Soutenance_v2.pptx
+++ b/présentation/LyonFlow_Bloc4_Soutenance_v2.pptx
@@ -12361,7 +12361,7 @@
                 <a:ea typeface="Calibri" pitchFamily="34" charset="-122"/>
                 <a:cs typeface="Calibri" pitchFamily="34" charset="-120"/>
               </a:rPr>
-              <a:t>Prometheus + Grafana + Alertmanager + 3 exporters</a:t>
+              <a:t>Cron + Telegram : watchdog 5 min, DAGs 30 min</a:t>
             </a:r>
             <a:endParaRPr lang="en-US" sz="1200" dirty="0"/>
           </a:p>
@@ -12379,7 +12379,7 @@
                 <a:ea typeface="Calibri" pitchFamily="34" charset="-122"/>
                 <a:cs typeface="Calibri" pitchFamily="34" charset="-120"/>
               </a:rPr>
-              <a:t>Redéployé et vérifié le 2026-07-02 : 5/5 cibles up</a:t>
+              <a:t>Hystérésis 20 % / 15 %, alerte si backup échoue</a:t>
             </a:r>
             <a:endParaRPr lang="en-US" sz="1200" dirty="0"/>
           </a:p>
@@ -12397,7 +12397,7 @@
                 <a:ea typeface="Calibri" pitchFamily="34" charset="-122"/>
                 <a:cs typeface="Calibri" pitchFamily="34" charset="-120"/>
               </a:rPr>
-              <a:t>7 groupes de règles chargés, Alertmanager lié</a:t>
+              <a:t>Cible : Prometheus + Grafana (compose prêt)</a:t>
             </a:r>
             <a:endParaRPr lang="en-US" sz="1200" dirty="0"/>
           </a:p>
@@ -12433,7 +12433,7 @@
                 <a:ea typeface="Calibri" pitchFamily="34" charset="-122"/>
                 <a:cs typeface="Calibri" pitchFamily="34" charset="-120"/>
               </a:rPr>
-              <a:t>scripts/healthcheck-vps.sh — 20 contrôles bout en bout</a:t>
+              <a:t>scripts/healthcheck-vps.sh — 33 contrôles bout en bout</a:t>
             </a:r>
             <a:endParaRPr lang="en-US" sz="1200" dirty="0"/>
           </a:p>
@@ -12880,7 +12880,7 @@
                 <a:ea typeface="Calibri" pitchFamily="34" charset="-122"/>
                 <a:cs typeface="Calibri" pitchFamily="34" charset="-120"/>
               </a:rPr>
-              <a:t>8+6</a:t>
+              <a:t>8</a:t>
             </a:r>
             <a:endParaRPr lang="en-US" sz="2200" dirty="0"/>
           </a:p>
@@ -12936,7 +12936,7 @@
                 <a:ea typeface="Calibri" pitchFamily="34" charset="-122"/>
                 <a:cs typeface="Calibri" pitchFamily="34" charset="-120"/>
               </a:rPr>
-              <a:t>+ monitoring</a:t>
+              <a:t>+ alertes Telegram</a:t>
             </a:r>
             <a:endParaRPr lang="en-US" sz="1000" dirty="0"/>
           </a:p>
@@ -13194,7 +13194,7 @@
                 <a:ea typeface="Calibri" pitchFamily="34" charset="-122"/>
                 <a:cs typeface="Calibri" pitchFamily="34" charset="-120"/>
               </a:rPr>
-              <a:t>(offsite en attente)</a:t>
+              <a:t>→ Google Drive</a:t>
             </a:r>
             <a:endParaRPr lang="en-US" sz="1000" dirty="0"/>
           </a:p>
@@ -13289,7 +13289,7 @@
                 <a:ea typeface="Calibri" pitchFamily="34" charset="-122"/>
                 <a:cs typeface="Calibri" pitchFamily="34" charset="-120"/>
               </a:rPr>
-              <a:t>+ monitoring : prometheus · grafana · alertmanager · node-exporter · postgres-exporter · nginx-exporter</a:t>
+              <a:t>+ monitoring : cron + alertes Telegram (cible : prometheus · grafana · alertmanager)</a:t>
             </a:r>
             <a:endParaRPr lang="en-US" sz="1250" dirty="0"/>
           </a:p>
@@ -23747,7 +23747,7 @@
                             <a:srgbClr val="1B2A4A"/>
                           </a:solidFill>
                         </a:rPr>
-                        <a:t>Prometheus + Alertmanager + Grafana (redéployé 2026-07-02)</a:t>
+                        <a:t>Cron + alertes Telegram (cible : Prometheus/Grafana)</a:t>
                       </a:r>
                       <a:endParaRPr lang="en-US" sz="1150" dirty="0"/>
                     </a:p>

</xml_diff>

<commit_message>
docs: 638 tests passants, vigilance réactivée (26 DAGs actifs + 2 pausés)
- Présentation et doc Bloc 4 : 638 tests passent, 0 échec ; 26 actifs +
  2 pausés ; ligne vigilance de l'annexe DAG, frise horaire et diagramme 04
  mis à jour.
- AGENTS.md : retrait de « test_error_display 3 failures » (faux), commande
  pytest fiable (doublons iCloud), note vigilance, mypy en cours.
- CHANGELOG : vigilance et tests dans la section Sprint 26.
</commit_message>
<xml_diff>
--- a/présentation/LyonFlow_Bloc4_Soutenance_v2.pptx
+++ b/présentation/LyonFlow_Bloc4_Soutenance_v2.pptx
@@ -14890,7 +14890,7 @@
                 <a:ea typeface="Calibri" pitchFamily="34" charset="-122"/>
                 <a:cs typeface="Calibri" pitchFamily="34" charset="-120"/>
               </a:rPr>
-              <a:t>631</a:t>
+              <a:t>638</a:t>
             </a:r>
             <a:endParaRPr lang="en-US" sz="2200" dirty="0"/>
           </a:p>
@@ -20030,7 +20030,7 @@
                 <a:ea typeface="Calibri" pitchFamily="34" charset="-122"/>
                 <a:cs typeface="Calibri" pitchFamily="34" charset="-120"/>
               </a:rPr>
-              <a:t>631</a:t>
+              <a:t>638</a:t>
             </a:r>
             <a:endParaRPr lang="en-US" sz="2200" dirty="0"/>
           </a:p>
@@ -25054,7 +25054,7 @@
                 <a:ea typeface="Calibri" pitchFamily="34" charset="-122"/>
                 <a:cs typeface="Calibri" pitchFamily="34" charset="-120"/>
               </a:rPr>
-              <a:t>(25 actifs + 3 pausés)</a:t>
+              <a:t>(26 actifs + 2 pausés)</a:t>
             </a:r>
             <a:endParaRPr lang="en-US" sz="1000" dirty="0"/>
           </a:p>

</xml_diff>